<commit_message>
Ensure author name, college affiliation (VIT), and email are prominently displayed across all paper templates and presentation
</commit_message>
<xml_diff>
--- a/docs/presentation/Handwritten_Text_Recognition_MNC_Keynote.pptx
+++ b/docs/presentation/Handwritten_Text_Recognition_MNC_Keynote.pptx
@@ -3186,15 +3186,15 @@
           </a:p>
           <a:p>
             <a:pPr>
-              <a:defRPr sz="1200">
-                <a:solidFill>
-                  <a:srgbClr val="38BDF8"/>
+              <a:defRPr sz="1300">
+                <a:solidFill>
+                  <a:srgbClr val="8C9BB9"/>
                 </a:solidFill>
                 <a:latin typeface="Calibri"/>
               </a:defRPr>
             </a:pPr>
             <a:r>
-              <a:t>Author: A. Venkata Balaji | Target Venue: IEEE Access</a:t>
+              <a:t>Author: A. Venkata Balaji | Vellore Institute of Technology (VIT) | galigastagiramma@gmail.com</a:t>
             </a:r>
           </a:p>
         </p:txBody>
@@ -6691,6 +6691,41 @@
           </a:p>
         </p:txBody>
       </p:sp>
+      <p:sp>
+        <p:nvSpPr>
+          <p:cNvPr id="3" name="TextBox 2"/>
+          <p:cNvSpPr txBox="1"/>
+          <p:nvPr/>
+        </p:nvSpPr>
+        <p:spPr>
+          <a:xfrm>
+            <a:off x="731520" y="6217920"/>
+            <a:ext cx="10725912" cy="457200"/>
+          </a:xfrm>
+          <a:prstGeom prst="rect">
+            <a:avLst/>
+          </a:prstGeom>
+          <a:noFill/>
+        </p:spPr>
+        <p:txBody>
+          <a:bodyPr wrap="square">
+            <a:spAutoFit/>
+          </a:bodyPr>
+          <a:lstStyle/>
+          <a:p>
+            <a:pPr>
+              <a:defRPr sz="1100">
+                <a:solidFill>
+                  <a:srgbClr val="00E5FF"/>
+                </a:solidFill>
+              </a:defRPr>
+            </a:pPr>
+            <a:r>
+              <a:t>Principal Investigator: A. Venkata Balaji | Vellore Institute of Technology (VIT) | galigastagiramma@gmail.com</a:t>
+            </a:r>
+          </a:p>
+        </p:txBody>
+      </p:sp>
     </p:spTree>
   </p:cSld>
   <p:clrMapOvr>

</xml_diff>